<commit_message>
Finished poster and updated README
</commit_message>
<xml_diff>
--- a/poster/Rishab Alagharu - WaferDetect GHP 63 CS Poster.pptx
+++ b/poster/Rishab Alagharu - WaferDetect GHP 63 CS Poster.pptx
@@ -12304,7 +12304,7 @@
         </p:nvSpPr>
         <p:spPr>
           <a:xfrm>
-            <a:off x="9191837" y="17208037"/>
+            <a:off x="9191836" y="17563800"/>
             <a:ext cx="7761541" cy="2740996"/>
           </a:xfrm>
           <a:prstGeom prst="roundRect">
@@ -12668,7 +12668,7 @@
         </p:blipFill>
         <p:spPr>
           <a:xfrm>
-            <a:off x="9562748" y="17364354"/>
+            <a:off x="9562747" y="17720117"/>
             <a:ext cx="2308322" cy="2308322"/>
           </a:xfrm>
           <a:prstGeom prst="rect">
@@ -12698,7 +12698,7 @@
         </p:blipFill>
         <p:spPr>
           <a:xfrm>
-            <a:off x="12241981" y="17893658"/>
+            <a:off x="12241980" y="18249421"/>
             <a:ext cx="4313992" cy="1240273"/>
           </a:xfrm>
           <a:prstGeom prst="rect">
@@ -13236,6 +13236,222 @@
           <a:xfrm>
             <a:off x="19461411" y="16579139"/>
             <a:ext cx="4265156" cy="4265156"/>
+          </a:xfrm>
+          <a:prstGeom prst="rect">
+            <a:avLst/>
+          </a:prstGeom>
+        </p:spPr>
+      </p:pic>
+      <p:pic>
+        <p:nvPicPr>
+          <p:cNvPr id="15" name="Graphic 14">
+            <a:extLst>
+              <a:ext uri="{FF2B5EF4-FFF2-40B4-BE49-F238E27FC236}">
+                <a16:creationId xmlns:a16="http://schemas.microsoft.com/office/drawing/2014/main" id="{E14043D7-57DB-0211-993F-317469A3C978}"/>
+              </a:ext>
+            </a:extLst>
+          </p:cNvPr>
+          <p:cNvPicPr>
+            <a:picLocks noChangeAspect="1"/>
+          </p:cNvPicPr>
+          <p:nvPr/>
+        </p:nvPicPr>
+        <p:blipFill>
+          <a:blip>
+            <a:extLst>
+              <a:ext uri="{96DAC541-7B7A-43D3-8B79-37D633B846F1}">
+                <asvg:svgBlip xmlns:asvg="http://schemas.microsoft.com/office/drawing/2016/SVG/main" r:embed="rId15"/>
+              </a:ext>
+            </a:extLst>
+          </a:blip>
+          <a:stretch>
+            <a:fillRect/>
+          </a:stretch>
+        </p:blipFill>
+        <p:spPr>
+          <a:xfrm>
+            <a:off x="9515602" y="15843855"/>
+            <a:ext cx="1090545" cy="1090545"/>
+          </a:xfrm>
+          <a:prstGeom prst="rect">
+            <a:avLst/>
+          </a:prstGeom>
+        </p:spPr>
+      </p:pic>
+      <p:pic>
+        <p:nvPicPr>
+          <p:cNvPr id="20" name="Graphic 19">
+            <a:extLst>
+              <a:ext uri="{FF2B5EF4-FFF2-40B4-BE49-F238E27FC236}">
+                <a16:creationId xmlns:a16="http://schemas.microsoft.com/office/drawing/2014/main" id="{C573B8F9-0A49-A195-9C89-41EB3E62F6B4}"/>
+              </a:ext>
+            </a:extLst>
+          </p:cNvPr>
+          <p:cNvPicPr>
+            <a:picLocks noChangeAspect="1"/>
+          </p:cNvPicPr>
+          <p:nvPr/>
+        </p:nvPicPr>
+        <p:blipFill>
+          <a:blip>
+            <a:extLst>
+              <a:ext uri="{96DAC541-7B7A-43D3-8B79-37D633B846F1}">
+                <asvg:svgBlip xmlns:asvg="http://schemas.microsoft.com/office/drawing/2016/SVG/main" r:embed="rId16"/>
+              </a:ext>
+            </a:extLst>
+          </a:blip>
+          <a:stretch>
+            <a:fillRect/>
+          </a:stretch>
+        </p:blipFill>
+        <p:spPr>
+          <a:xfrm>
+            <a:off x="10772434" y="15786703"/>
+            <a:ext cx="932839" cy="1127761"/>
+          </a:xfrm>
+          <a:prstGeom prst="rect">
+            <a:avLst/>
+          </a:prstGeom>
+        </p:spPr>
+      </p:pic>
+      <p:pic>
+        <p:nvPicPr>
+          <p:cNvPr id="23" name="Graphic 22">
+            <a:extLst>
+              <a:ext uri="{FF2B5EF4-FFF2-40B4-BE49-F238E27FC236}">
+                <a16:creationId xmlns:a16="http://schemas.microsoft.com/office/drawing/2014/main" id="{0F7525F2-94E3-5981-BD7F-AF57C4418803}"/>
+              </a:ext>
+            </a:extLst>
+          </p:cNvPr>
+          <p:cNvPicPr>
+            <a:picLocks noChangeAspect="1"/>
+          </p:cNvPicPr>
+          <p:nvPr/>
+        </p:nvPicPr>
+        <p:blipFill>
+          <a:blip>
+            <a:extLst>
+              <a:ext uri="{96DAC541-7B7A-43D3-8B79-37D633B846F1}">
+                <asvg:svgBlip xmlns:asvg="http://schemas.microsoft.com/office/drawing/2016/SVG/main" r:embed="rId17"/>
+              </a:ext>
+            </a:extLst>
+          </a:blip>
+          <a:stretch>
+            <a:fillRect/>
+          </a:stretch>
+        </p:blipFill>
+        <p:spPr>
+          <a:xfrm>
+            <a:off x="14379594" y="15836050"/>
+            <a:ext cx="1176804" cy="1098350"/>
+          </a:xfrm>
+          <a:prstGeom prst="rect">
+            <a:avLst/>
+          </a:prstGeom>
+        </p:spPr>
+      </p:pic>
+      <p:pic>
+        <p:nvPicPr>
+          <p:cNvPr id="25" name="Graphic 24">
+            <a:extLst>
+              <a:ext uri="{FF2B5EF4-FFF2-40B4-BE49-F238E27FC236}">
+                <a16:creationId xmlns:a16="http://schemas.microsoft.com/office/drawing/2014/main" id="{CB810942-4386-1B13-910F-9086BDB8E67D}"/>
+              </a:ext>
+            </a:extLst>
+          </p:cNvPr>
+          <p:cNvPicPr>
+            <a:picLocks noChangeAspect="1"/>
+          </p:cNvPicPr>
+          <p:nvPr/>
+        </p:nvPicPr>
+        <p:blipFill>
+          <a:blip>
+            <a:extLst>
+              <a:ext uri="{96DAC541-7B7A-43D3-8B79-37D633B846F1}">
+                <asvg:svgBlip xmlns:asvg="http://schemas.microsoft.com/office/drawing/2016/SVG/main" r:embed="rId18"/>
+              </a:ext>
+            </a:extLst>
+          </a:blip>
+          <a:stretch>
+            <a:fillRect/>
+          </a:stretch>
+        </p:blipFill>
+        <p:spPr>
+          <a:xfrm>
+            <a:off x="13135219" y="15853670"/>
+            <a:ext cx="1080730" cy="1080730"/>
+          </a:xfrm>
+          <a:prstGeom prst="rect">
+            <a:avLst/>
+          </a:prstGeom>
+        </p:spPr>
+      </p:pic>
+      <p:pic>
+        <p:nvPicPr>
+          <p:cNvPr id="29" name="Graphic 28">
+            <a:extLst>
+              <a:ext uri="{FF2B5EF4-FFF2-40B4-BE49-F238E27FC236}">
+                <a16:creationId xmlns:a16="http://schemas.microsoft.com/office/drawing/2014/main" id="{D20414FD-125C-4465-56A8-8D5CC967601C}"/>
+              </a:ext>
+            </a:extLst>
+          </p:cNvPr>
+          <p:cNvPicPr>
+            <a:picLocks noChangeAspect="1"/>
+          </p:cNvPicPr>
+          <p:nvPr/>
+        </p:nvPicPr>
+        <p:blipFill>
+          <a:blip>
+            <a:extLst>
+              <a:ext uri="{96DAC541-7B7A-43D3-8B79-37D633B846F1}">
+                <asvg:svgBlip xmlns:asvg="http://schemas.microsoft.com/office/drawing/2016/SVG/main" r:embed="rId19"/>
+              </a:ext>
+            </a:extLst>
+          </a:blip>
+          <a:stretch>
+            <a:fillRect/>
+          </a:stretch>
+        </p:blipFill>
+        <p:spPr>
+          <a:xfrm>
+            <a:off x="11871560" y="15843855"/>
+            <a:ext cx="1098351" cy="1098351"/>
+          </a:xfrm>
+          <a:prstGeom prst="rect">
+            <a:avLst/>
+          </a:prstGeom>
+        </p:spPr>
+      </p:pic>
+      <p:pic>
+        <p:nvPicPr>
+          <p:cNvPr id="33" name="Graphic 32">
+            <a:extLst>
+              <a:ext uri="{FF2B5EF4-FFF2-40B4-BE49-F238E27FC236}">
+                <a16:creationId xmlns:a16="http://schemas.microsoft.com/office/drawing/2014/main" id="{310BEB21-0FE5-C324-0BA2-9D2E47882EE1}"/>
+              </a:ext>
+            </a:extLst>
+          </p:cNvPr>
+          <p:cNvPicPr>
+            <a:picLocks noChangeAspect="1"/>
+          </p:cNvPicPr>
+          <p:nvPr/>
+        </p:nvPicPr>
+        <p:blipFill>
+          <a:blip>
+            <a:extLst>
+              <a:ext uri="{96DAC541-7B7A-43D3-8B79-37D633B846F1}">
+                <asvg:svgBlip xmlns:asvg="http://schemas.microsoft.com/office/drawing/2016/SVG/main" r:embed="rId20"/>
+              </a:ext>
+            </a:extLst>
+          </a:blip>
+          <a:stretch>
+            <a:fillRect/>
+          </a:stretch>
+        </p:blipFill>
+        <p:spPr>
+          <a:xfrm flipH="1">
+            <a:off x="15720043" y="15843855"/>
+            <a:ext cx="1098351" cy="1084039"/>
           </a:xfrm>
           <a:prstGeom prst="rect">
             <a:avLst/>

</xml_diff>